<commit_message>
fix: soyadı AVCI → AVCİ düzeltmesi (tüm dokümanlarda)
Etkilenen dosyalar:
- docs/generate-srs.py → SRS-Restoran-POS-v1.1.0.docx
- docs/generate-kilavuz.py → KULLANIM-KILAVUZU-Restoran-POS.docx
- docs/generate-tanitim.py → PROJE-TANITIM-Restoran-POS.docx
- docs/generate-sunum.py → SUNUM-Restoran-POS-v1.1.0.pptx
- README-TESLIM.md

Co-Authored-By: Claude Sonnet 4.6 <noreply@anthropic.com>
</commit_message>
<xml_diff>
--- a/docs/SUNUM-Restoran-POS-v1.1.0.pptx
+++ b/docs/SUNUM-Restoran-POS-v1.1.0.pptx
@@ -3453,7 +3453,7 @@
                 </a:solidFill>
                 <a:latin typeface="Calibri"/>
               </a:rPr>
-              <a:t>İlhan AVCI  |  220357008</a:t>
+              <a:t>İlhan AVCİ  |  220357008</a:t>
             </a:r>
           </a:p>
         </p:txBody>
@@ -13048,7 +13048,7 @@
                 </a:solidFill>
                 <a:latin typeface="Calibri"/>
               </a:rPr>
-              <a:t>İlhan AVCI  ·  220357008</a:t>
+              <a:t>İlhan AVCİ  ·  220357008</a:t>
             </a:r>
           </a:p>
         </p:txBody>

</xml_diff>